<commit_message>
[COF-48] Rebuild the deck from the refused-write source
</commit_message>
<xml_diff>
--- a/docs/deck/out/lumen-dispute-copilot-2026-10-29.pptx
+++ b/docs/deck/out/lumen-dispute-copilot-2026-10-29.pptx
@@ -1309,7 +1309,7 @@
           <a:p>
             <a:r>
               <a:rPr lang="en-US" dirty="0"/>
-              <a:t>Here is the object the pipeline produces. Ten keys, fixed before any prose exists: classification, route, facts from the transaction record, the deadline counted from the reported date, and six citations. The hash is what a human approves. If a field changes after approval, the server refuses the write with 403. That refusal is the gate working.</a:t>
+              <a:t>Here is the object the pipeline produces. Ten keys, fixed before any prose exists: classification, route, facts from the transaction record, the deadline counted from the reported date, and six citations. The hash is what a human approves. If a field changes after approval, the runner refuses the draft before it sends anything, so no write is ever attempted. That refusal is the gate working.</a:t>
             </a:r>
             <a:endParaRPr lang="en-US" dirty="0"/>
           </a:p>
@@ -1397,7 +1397,7 @@
           <a:p>
             <a:r>
               <a:rPr lang="en-US" dirty="0"/>
-              <a:t>Five cases, five outcomes, all on main. D01 walks the gate: draft, approval bound to the hash, then 403 and 409 when the key changes. D05 and D06 decide a contradiction by routing to manual review and citing both sources. D10 exercises the retry ladder on an injected 503: three attempts, one retry, a draft in 1.3 seconds. D09 is a redelivery of D02 and is deduplicated. D08 stores the instruction-shaped note as evidence and never obeys it.</a:t>
+              <a:t>Five cases, five outcomes, all on main. D01 walks the gate: draft, approval bound to the hash, a changed draft stopped before any write, and 409 on a second record. D05 and D06 decide a contradiction by routing to manual review and citing both sources. D10 exercises the retry ladder on an injected 503: three attempts, one retry, a draft in 1.3 seconds. D09 is a redelivery of D02 and is deduplicated. D08 stores the instruction-shaped note as evidence and never obeys it.</a:t>
             </a:r>
             <a:endParaRPr lang="en-US" dirty="0"/>
           </a:p>
@@ -1837,7 +1837,7 @@
           <a:p>
             <a:r>
               <a:rPr lang="en-US" dirty="0"/>
-              <a:t>One delivered band and one gap list. On main: all twelve cases, the record, the 403 and the 409, and a wired retry ladder. The gaps are named: reviewer identity is not started, the model route is merged but off with no approved live run, update and close are blocked by Gate U, and the wrapped statement has no line limit. Not attempted: a user interface, OCR, production identity, adjudication, and the deployment shape, which is one node, SQLite, and no reviewer identity.</a:t>
+              <a:t>One delivered band and one gap list. On main: all twelve cases, the record, the changed-draft refusal and the 409, and a wired retry ladder. The gaps are named: reviewer identity is not started, the model route is merged but off with no approved live run, update and close are blocked by Gate U, and the wrapped statement has no line limit. Not attempted: a user interface, OCR, production identity, adjudication, and the deployment shape, which is one node, SQLite, and no reviewer identity.</a:t>
             </a:r>
             <a:endParaRPr lang="en-US" dirty="0"/>
           </a:p>
@@ -2487,7 +2487,7 @@
       </p:sp>
       <p:pic>
         <p:nvPicPr>
-          <p:cNvPr id="9" name="Image 0" descr="D:\20-projects\credit-card-dispute\.worktrees\lane-deck\docs\deck\assets\motif_alpha.png">    </p:cNvPr>
+          <p:cNvPr id="9" name="Image 0" descr="D:\20-projects\credit-card-dispute\.worktrees\review-91\docs\deck\assets\motif_alpha.png">    </p:cNvPr>
           <p:cNvPicPr>
             <a:picLocks noChangeAspect="1"/>
           </p:cNvPicPr>
@@ -3496,7 +3496,7 @@
                 <a:ea typeface="Consolas" pitchFamily="34" charset="-122"/>
                 <a:cs typeface="Consolas" pitchFamily="34" charset="-120"/>
               </a:rPr>
-              <a:t>changed field             403</a:t>
+              <a:t>changed field             refused</a:t>
             </a:r>
             <a:endParaRPr lang="en-US" sz="1050" dirty="0"/>
           </a:p>
@@ -3538,7 +3538,7 @@
                 <a:ea typeface="Consolas" pitchFamily="34" charset="-122"/>
                 <a:cs typeface="Consolas" pitchFamily="34" charset="-120"/>
               </a:rPr>
-              <a:t>   approval_missing_or_draft_changed</a:t>
+              <a:t>   before any POST: nothing written</a:t>
             </a:r>
             <a:endParaRPr lang="en-US" sz="1050" dirty="0"/>
           </a:p>
@@ -5553,7 +5553,7 @@
         <p:spPr>
           <a:xfrm>
             <a:off x="566928" y="3419856"/>
-            <a:ext cx="3291840" cy="932688"/>
+            <a:ext cx="3291840" cy="1152144"/>
           </a:xfrm>
           <a:prstGeom prst="rect">
             <a:avLst/>
@@ -5580,7 +5580,7 @@
                 <a:ea typeface="Segoe UI" pitchFamily="34" charset="-122"/>
                 <a:cs typeface="Segoe UI" pitchFamily="34" charset="-120"/>
               </a:rPr>
-              <a:t>Idempotency. The approval bound to the draft hash, 403 and 409 live, and the evidence pack behind every number here.</a:t>
+              <a:t>Idempotency. The approval bound to the draft hash, a changed draft stopped before any write, 409 live, and the evidence pack behind every number here.</a:t>
             </a:r>
             <a:endParaRPr lang="en-US" sz="1350" dirty="0"/>
           </a:p>
@@ -6724,7 +6724,7 @@
       </p:sp>
       <p:pic>
         <p:nvPicPr>
-          <p:cNvPr id="13" name="Image 0" descr="D:\20-projects\credit-card-dispute\.worktrees\lane-deck\docs\deck\assets\motif_alpha.png">    </p:cNvPr>
+          <p:cNvPr id="13" name="Image 0" descr="D:\20-projects\credit-card-dispute\.worktrees\review-91\docs\deck\assets\motif_alpha.png">    </p:cNvPr>
           <p:cNvPicPr>
             <a:picLocks noChangeAspect="1"/>
           </p:cNvPicPr>
@@ -14115,7 +14115,7 @@
                 <a:ea typeface="Consolas" pitchFamily="34" charset="-122"/>
                 <a:cs typeface="Consolas" pitchFamily="34" charset="-120"/>
               </a:rPr>
-              <a:t>403 changed draft</a:t>
+              <a:t>changed draft: refused, no write</a:t>
             </a:r>
             <a:endParaRPr lang="en-US" sz="1000" dirty="0"/>
           </a:p>
@@ -14873,7 +14873,7 @@
                 <a:ea typeface="Segoe UI" pitchFamily="34" charset="-122"/>
                 <a:cs typeface="Segoe UI" pitchFamily="34" charset="-120"/>
               </a:rPr>
-              <a:t>Review requested, hash bound, record written. 201, then a 200 replay; 403 on a changed field; 409 on a second record.</a:t>
+              <a:t>Hash bound, approved, record written: 201, then a 200 replay. A changed draft stops before any write; 409 on a second record.</a:t>
             </a:r>
             <a:endParaRPr lang="en-US" sz="1250" dirty="0"/>
           </a:p>
@@ -17560,7 +17560,7 @@
       </p:sp>
       <p:pic>
         <p:nvPicPr>
-          <p:cNvPr id="10" name="Image 0" descr="D:\20-projects\credit-card-dispute\.worktrees\lane-deck\docs\deck\assets\pipeline_bare.png">    </p:cNvPr>
+          <p:cNvPr id="10" name="Image 0" descr="D:\20-projects\credit-card-dispute\.worktrees\review-91\docs\deck\assets\pipeline_bare.png">    </p:cNvPr>
           <p:cNvPicPr>
             <a:picLocks noChangeAspect="1"/>
           </p:cNvPicPr>
@@ -18908,7 +18908,7 @@
       </p:sp>
       <p:pic>
         <p:nvPicPr>
-          <p:cNvPr id="10" name="Image 0" descr="D:\20-projects\credit-card-dispute\.worktrees\lane-deck\docs\deck\assets\boundary_bare.png">    </p:cNvPr>
+          <p:cNvPr id="10" name="Image 0" descr="D:\20-projects\credit-card-dispute\.worktrees\review-91\docs\deck\assets\boundary_bare.png">    </p:cNvPr>
           <p:cNvPicPr>
             <a:picLocks noChangeAspect="1"/>
           </p:cNvPicPr>
@@ -19338,7 +19338,7 @@
                 <a:ea typeface="Segoe UI" pitchFamily="34" charset="-122"/>
                 <a:cs typeface="Segoe UI" pitchFamily="34" charset="-120"/>
               </a:rPr>
-              <a:t>Every case builds. D05 and D06 route to manual review, D07 and D10 retry, D09 deduplicates. The review gate, the 403, the 409 and the record write are wired.</a:t>
+              <a:t>Every case builds. D05 and D06 route to manual review, D07 and D10 retry, D09 deduplicates. The review gate, the changed-draft refusal, the 409 and the record write are wired.</a:t>
             </a:r>
             <a:endParaRPr lang="en-US" sz="1300" dirty="0"/>
           </a:p>

</xml_diff>